<commit_message>
geneNetworking: fix Tier-4 edge-count (>=7/10 mean ~7,200 not ~7,600) in report + deck
</commit_message>
<xml_diff>
--- a/geneNetworking/geneNetworking.pptx
+++ b/geneNetworking/geneNetworking.pptx
@@ -5705,13 +5705,13 @@
           <a:p>
             <a:pPr algn="l"/>
             <a:r>
-              <a:rPr sz="3000" b="1">
+              <a:rPr sz="2600" b="1">
                 <a:solidFill>
                   <a:srgbClr val="1F3A5F"/>
                 </a:solidFill>
                 <a:latin typeface="Calibri"/>
               </a:rPr>
-              <a:t>Single-Cell Summary — Synthesis &amp; Validation</a:t>
+              <a:t>Tier 4 — Motif-Pruned, Bootstrap-Stabilized Regulons</a:t>
             </a:r>
           </a:p>
         </p:txBody>
@@ -5724,43 +5724,8 @@
         </p:nvSpPr>
         <p:spPr>
           <a:xfrm>
-            <a:off x="11247120" y="6355080"/>
-            <a:ext cx="822960" cy="365760"/>
-          </a:xfrm>
-          <a:prstGeom prst="rect">
-            <a:avLst/>
-          </a:prstGeom>
-          <a:noFill/>
-        </p:spPr>
-        <p:txBody>
-          <a:bodyPr wrap="square">
-            <a:spAutoFit/>
-          </a:bodyPr>
-          <a:lstStyle/>
-          <a:p>
-            <a:pPr algn="r"/>
-            <a:r>
-              <a:rPr sz="1100" b="0">
-                <a:solidFill>
-                  <a:srgbClr val="666666"/>
-                </a:solidFill>
-                <a:latin typeface="Calibri"/>
-              </a:rPr>
-              <a:t>18 / 18</a:t>
-            </a:r>
-          </a:p>
-        </p:txBody>
-      </p:sp>
-      <p:sp>
-        <p:nvSpPr>
-          <p:cNvPr id="5" name="TextBox 4"/>
-          <p:cNvSpPr txBox="1"/>
-          <p:nvPr/>
-        </p:nvSpPr>
-        <p:spPr>
-          <a:xfrm>
             <a:off x="640080" y="1325880"/>
-            <a:ext cx="6949440" cy="5120640"/>
+            <a:ext cx="6309360" cy="5120640"/>
           </a:xfrm>
           <a:prstGeom prst="rect">
             <a:avLst/>
@@ -5785,7 +5750,7 @@
                 </a:solidFill>
                 <a:latin typeface="Calibri"/>
               </a:rPr>
-              <a:t>▸ SC2.2 synthesis (fuses with Phase A)</a:t>
+              <a:t>▸ Full pySCENIC on the 4 headline cell types × 3 species (12 units, ~26 h)</a:t>
             </a:r>
           </a:p>
           <a:p>
@@ -5801,7 +5766,23 @@
                 </a:solidFill>
                 <a:latin typeface="Calibri"/>
               </a:rPr>
-              <a:t>– Phylo-signal at tissue level can reflect EITHER conserved cell-intrinsic regulation OR conserved composition</a:t>
+              <a:t>– GRNBoost2 → cisTarget motif pruning → AUCell, 10 bootstrap runs each; run natively (Docker)</a:t>
+            </a:r>
+          </a:p>
+          <a:p>
+            <a:pPr>
+              <a:spcBef>
+                <a:spcPts val="800"/>
+              </a:spcBef>
+            </a:pPr>
+            <a:r>
+              <a:rPr sz="1500" b="1">
+                <a:solidFill>
+                  <a:srgbClr val="444444"/>
+                </a:solidFill>
+                <a:latin typeface="Calibri"/>
+              </a:rPr>
+              <a:t>▸ The conservation thesis survives the stricter method</a:t>
             </a:r>
           </a:p>
           <a:p>
@@ -5817,7 +5798,7 @@
                 </a:solidFill>
                 <a:latin typeface="Calibri"/>
               </a:rPr>
-              <a:t>– M14/plasma cell: high phylo-signal (K=0.40) + conserved regulator (XBP1), divergent targets</a:t>
+              <a:t>– Regulator-set conservation 3.2–5.0× above random floor (monocyte 4.7×, T cell 5.0×)</a:t>
             </a:r>
           </a:p>
           <a:p>
@@ -5833,19 +5814,7 @@
                 </a:solidFill>
                 <a:latin typeface="Calibri"/>
               </a:rPr>
-              <a:t>– M11/adipose: significant phylo-signal but composition-driven — single-cell distinguishes the two</a:t>
-            </a:r>
-          </a:p>
-          <a:p>
-            <a:pPr lvl="1"/>
-            <a:r>
-              <a:rPr sz="1200">
-                <a:solidFill>
-                  <a:srgbClr val="666666"/>
-                </a:solidFill>
-                <a:latin typeface="Calibri"/>
-              </a:rPr>
-              <a:t>(n=6 reliably-mapped modules — exploratory; strongest phylo-signal modules are data-limited)</a:t>
+              <a:t>– Regulators conserved 3.5× more than target wiring — same ordering as co-expression (2.4×)</a:t>
             </a:r>
           </a:p>
           <a:p>
@@ -5861,7 +5830,7 @@
                 </a:solidFill>
                 <a:latin typeface="Calibri"/>
               </a:rPr>
-              <a:t>▸ SC-Tier 3 validation</a:t>
+              <a:t>▸ Canonical masters survive motif pruning where it matters</a:t>
             </a:r>
           </a:p>
           <a:p>
@@ -5877,7 +5846,7 @@
                 </a:solidFill>
                 <a:latin typeface="Calibri"/>
               </a:rPr>
-              <a:t>– Motif support: mean 83% of top regulators carry a JASPAR motif</a:t>
+              <a:t>– XBP1 (plasma, human+mouse) · HNF4A (hepatocyte, mouse+lemur) · CEBPB+FOS (monocyte, all 3)</a:t>
             </a:r>
           </a:p>
           <a:p>
@@ -5893,7 +5862,23 @@
                 </a:solidFill>
                 <a:latin typeface="Calibri"/>
               </a:rPr>
-              <a:t>– Cross-species held-out (h+m→lemur) accuracy tracks SC2.1 conservation at ρ=0.79</a:t>
+              <a:t>– Pruning is strict (~28% of top-20 retained); the lineage masters are among the survivors</a:t>
+            </a:r>
+          </a:p>
+          <a:p>
+            <a:pPr>
+              <a:spcBef>
+                <a:spcPts val="800"/>
+              </a:spcBef>
+            </a:pPr>
+            <a:r>
+              <a:rPr sz="1500" b="1">
+                <a:solidFill>
+                  <a:srgbClr val="444444"/>
+                </a:solidFill>
+                <a:latin typeface="Calibri"/>
+              </a:rPr>
+              <a:t>▸ Bootstrap stability = a reproducible network core</a:t>
             </a:r>
           </a:p>
           <a:p>
@@ -5909,30 +5894,14 @@
                 </a:solidFill>
                 <a:latin typeface="Calibri"/>
               </a:rPr>
-              <a:t>– DoRothEA: cell-type AUROC ~0.57 &lt; bulk 0.67 — single-cell buys resolution, not gold-standard breadth</a:t>
-            </a:r>
-          </a:p>
-          <a:p>
-            <a:pPr>
-              <a:spcBef>
-                <a:spcPts val="800"/>
-              </a:spcBef>
-            </a:pPr>
-            <a:r>
-              <a:rPr sz="1500" b="1">
-                <a:solidFill>
-                  <a:srgbClr val="444444"/>
-                </a:solidFill>
-                <a:latin typeface="Calibri"/>
-              </a:rPr>
-              <a:t>▸ Status: SC-Tiers 1–3 complete; Tier 4 (full pySCENIC, motif-pruned + bootstrap) complete for 4 headline cell types (see slide 17)</a:t>
+              <a:t>– ~3,900 edges recur in ≥8/10 bootstraps per unit (~7,200 at ≥7/10)</a:t>
             </a:r>
           </a:p>
         </p:txBody>
       </p:sp>
       <p:pic>
         <p:nvPicPr>
-          <p:cNvPr id="6" name="Picture 5" descr="v97ee8316_sc_synthesis.png"/>
+          <p:cNvPr id="5" name="Picture 4" descr="sc_tier4_summary.png"/>
           <p:cNvPicPr>
             <a:picLocks noChangeAspect="1"/>
           </p:cNvPicPr>
@@ -5946,8 +5915,8 @@
         </p:blipFill>
         <p:spPr>
           <a:xfrm>
-            <a:off x="7635240" y="1554480"/>
-            <a:ext cx="4206240" cy="2085500"/>
+            <a:off x="7040880" y="1417320"/>
+            <a:ext cx="4846320" cy="1343497"/>
           </a:xfrm>
           <a:prstGeom prst="rect">
             <a:avLst/>
@@ -5956,14 +5925,14 @@
       </p:pic>
       <p:sp>
         <p:nvSpPr>
-          <p:cNvPr id="7" name="TextBox 6"/>
+          <p:cNvPr id="6" name="TextBox 5"/>
           <p:cNvSpPr txBox="1"/>
           <p:nvPr/>
         </p:nvSpPr>
         <p:spPr>
           <a:xfrm>
-            <a:off x="7635240" y="4709160"/>
-            <a:ext cx="4206240" cy="365760"/>
+            <a:off x="7040880" y="4617720"/>
+            <a:ext cx="4846320" cy="365760"/>
           </a:xfrm>
           <a:prstGeom prst="rect">
             <a:avLst/>
@@ -5984,7 +5953,42 @@
                 </a:solidFill>
                 <a:latin typeface="Calibri"/>
               </a:rPr>
-              <a:t>SC2.2: phylo-signal × preservation × cell-type regulon conservation</a:t>
+              <a:t>Tier-4 conservation, master survival, and stability (4 cell types)</a:t>
+            </a:r>
+          </a:p>
+        </p:txBody>
+      </p:sp>
+      <p:sp>
+        <p:nvSpPr>
+          <p:cNvPr id="7" name="TextBox 6"/>
+          <p:cNvSpPr txBox="1"/>
+          <p:nvPr/>
+        </p:nvSpPr>
+        <p:spPr>
+          <a:xfrm>
+            <a:off x="11247120" y="6355080"/>
+            <a:ext cx="822960" cy="365760"/>
+          </a:xfrm>
+          <a:prstGeom prst="rect">
+            <a:avLst/>
+          </a:prstGeom>
+          <a:noFill/>
+        </p:spPr>
+        <p:txBody>
+          <a:bodyPr wrap="square">
+            <a:spAutoFit/>
+          </a:bodyPr>
+          <a:lstStyle/>
+          <a:p>
+            <a:pPr algn="r"/>
+            <a:r>
+              <a:rPr sz="1100" b="0">
+                <a:solidFill>
+                  <a:srgbClr val="666666"/>
+                </a:solidFill>
+                <a:latin typeface="Calibri"/>
+              </a:rPr>
+              <a:t>17 / 18</a:t>
             </a:r>
           </a:p>
         </p:txBody>
@@ -6075,13 +6079,13 @@
           <a:p>
             <a:pPr algn="l"/>
             <a:r>
-              <a:rPr sz="2600" b="1">
+              <a:rPr sz="3000" b="1">
                 <a:solidFill>
                   <a:srgbClr val="1F3A5F"/>
                 </a:solidFill>
                 <a:latin typeface="Calibri"/>
               </a:rPr>
-              <a:t>Tier 4 — Motif-Pruned, Bootstrap-Stabilized Regulons</a:t>
+              <a:t>Single-Cell Summary — Synthesis &amp; Validation</a:t>
             </a:r>
           </a:p>
         </p:txBody>
@@ -6094,8 +6098,43 @@
         </p:nvSpPr>
         <p:spPr>
           <a:xfrm>
+            <a:off x="11247120" y="6355080"/>
+            <a:ext cx="822960" cy="365760"/>
+          </a:xfrm>
+          <a:prstGeom prst="rect">
+            <a:avLst/>
+          </a:prstGeom>
+          <a:noFill/>
+        </p:spPr>
+        <p:txBody>
+          <a:bodyPr wrap="square">
+            <a:spAutoFit/>
+          </a:bodyPr>
+          <a:lstStyle/>
+          <a:p>
+            <a:pPr algn="r"/>
+            <a:r>
+              <a:rPr sz="1100" b="0">
+                <a:solidFill>
+                  <a:srgbClr val="666666"/>
+                </a:solidFill>
+                <a:latin typeface="Calibri"/>
+              </a:rPr>
+              <a:t>18 / 18</a:t>
+            </a:r>
+          </a:p>
+        </p:txBody>
+      </p:sp>
+      <p:sp>
+        <p:nvSpPr>
+          <p:cNvPr id="5" name="TextBox 4"/>
+          <p:cNvSpPr txBox="1"/>
+          <p:nvPr/>
+        </p:nvSpPr>
+        <p:spPr>
+          <a:xfrm>
             <a:off x="640080" y="1325880"/>
-            <a:ext cx="6309360" cy="5120640"/>
+            <a:ext cx="6949440" cy="5120640"/>
           </a:xfrm>
           <a:prstGeom prst="rect">
             <a:avLst/>
@@ -6120,7 +6159,7 @@
                 </a:solidFill>
                 <a:latin typeface="Calibri"/>
               </a:rPr>
-              <a:t>▸ Full pySCENIC on the 4 headline cell types × 3 species (12 units, ~26 h)</a:t>
+              <a:t>▸ SC2.2 synthesis (fuses with Phase A)</a:t>
             </a:r>
           </a:p>
           <a:p>
@@ -6136,7 +6175,51 @@
                 </a:solidFill>
                 <a:latin typeface="Calibri"/>
               </a:rPr>
-              <a:t>– GRNBoost2 → cisTarget motif pruning → AUCell, 10 bootstrap runs each; run natively (Docker)</a:t>
+              <a:t>– Phylo-signal at tissue level can reflect EITHER conserved cell-intrinsic regulation OR conserved composition</a:t>
+            </a:r>
+          </a:p>
+          <a:p>
+            <a:pPr>
+              <a:spcBef>
+                <a:spcPts val="200"/>
+              </a:spcBef>
+            </a:pPr>
+            <a:r>
+              <a:rPr sz="1300">
+                <a:solidFill>
+                  <a:srgbClr val="666666"/>
+                </a:solidFill>
+                <a:latin typeface="Calibri"/>
+              </a:rPr>
+              <a:t>– M14/plasma cell: high phylo-signal (K=0.40) + conserved regulator (XBP1), divergent targets</a:t>
+            </a:r>
+          </a:p>
+          <a:p>
+            <a:pPr>
+              <a:spcBef>
+                <a:spcPts val="200"/>
+              </a:spcBef>
+            </a:pPr>
+            <a:r>
+              <a:rPr sz="1300">
+                <a:solidFill>
+                  <a:srgbClr val="666666"/>
+                </a:solidFill>
+                <a:latin typeface="Calibri"/>
+              </a:rPr>
+              <a:t>– M11/adipose: significant phylo-signal but composition-driven — single-cell distinguishes the two</a:t>
+            </a:r>
+          </a:p>
+          <a:p>
+            <a:pPr lvl="1"/>
+            <a:r>
+              <a:rPr sz="1200">
+                <a:solidFill>
+                  <a:srgbClr val="666666"/>
+                </a:solidFill>
+                <a:latin typeface="Calibri"/>
+              </a:rPr>
+              <a:t>(n=6 reliably-mapped modules — exploratory; strongest phylo-signal modules are data-limited)</a:t>
             </a:r>
           </a:p>
           <a:p>
@@ -6152,7 +6235,7 @@
                 </a:solidFill>
                 <a:latin typeface="Calibri"/>
               </a:rPr>
-              <a:t>▸ The conservation thesis survives the stricter method</a:t>
+              <a:t>▸ SC-Tier 3 validation</a:t>
             </a:r>
           </a:p>
           <a:p>
@@ -6168,7 +6251,7 @@
                 </a:solidFill>
                 <a:latin typeface="Calibri"/>
               </a:rPr>
-              <a:t>– Regulator-set conservation 3.2–5.0× above random floor (monocyte 4.7×, T cell 5.0×)</a:t>
+              <a:t>– Motif support: mean 83% of top regulators carry a JASPAR motif</a:t>
             </a:r>
           </a:p>
           <a:p>
@@ -6184,7 +6267,23 @@
                 </a:solidFill>
                 <a:latin typeface="Calibri"/>
               </a:rPr>
-              <a:t>– Regulators conserved 3.5× more than target wiring — same ordering as co-expression (2.4×)</a:t>
+              <a:t>– Cross-species held-out (h+m→lemur) accuracy tracks SC2.1 conservation at ρ=0.79</a:t>
+            </a:r>
+          </a:p>
+          <a:p>
+            <a:pPr>
+              <a:spcBef>
+                <a:spcPts val="200"/>
+              </a:spcBef>
+            </a:pPr>
+            <a:r>
+              <a:rPr sz="1300">
+                <a:solidFill>
+                  <a:srgbClr val="666666"/>
+                </a:solidFill>
+                <a:latin typeface="Calibri"/>
+              </a:rPr>
+              <a:t>– DoRothEA: cell-type AUROC ~0.57 &lt; bulk 0.67 — single-cell buys resolution, not gold-standard breadth</a:t>
             </a:r>
           </a:p>
           <a:p>
@@ -6200,78 +6299,14 @@
                 </a:solidFill>
                 <a:latin typeface="Calibri"/>
               </a:rPr>
-              <a:t>▸ Canonical masters survive motif pruning where it matters</a:t>
-            </a:r>
-          </a:p>
-          <a:p>
-            <a:pPr>
-              <a:spcBef>
-                <a:spcPts val="200"/>
-              </a:spcBef>
-            </a:pPr>
-            <a:r>
-              <a:rPr sz="1300">
-                <a:solidFill>
-                  <a:srgbClr val="666666"/>
-                </a:solidFill>
-                <a:latin typeface="Calibri"/>
-              </a:rPr>
-              <a:t>– XBP1 (plasma, human+mouse) · HNF4A (hepatocyte, mouse+lemur) · CEBPB+FOS (monocyte, all 3)</a:t>
-            </a:r>
-          </a:p>
-          <a:p>
-            <a:pPr>
-              <a:spcBef>
-                <a:spcPts val="200"/>
-              </a:spcBef>
-            </a:pPr>
-            <a:r>
-              <a:rPr sz="1300">
-                <a:solidFill>
-                  <a:srgbClr val="666666"/>
-                </a:solidFill>
-                <a:latin typeface="Calibri"/>
-              </a:rPr>
-              <a:t>– Pruning is strict (~28% of top-20 retained); the lineage masters are among the survivors</a:t>
-            </a:r>
-          </a:p>
-          <a:p>
-            <a:pPr>
-              <a:spcBef>
-                <a:spcPts val="800"/>
-              </a:spcBef>
-            </a:pPr>
-            <a:r>
-              <a:rPr sz="1500" b="1">
-                <a:solidFill>
-                  <a:srgbClr val="444444"/>
-                </a:solidFill>
-                <a:latin typeface="Calibri"/>
-              </a:rPr>
-              <a:t>▸ Bootstrap stability = a reproducible network core</a:t>
-            </a:r>
-          </a:p>
-          <a:p>
-            <a:pPr>
-              <a:spcBef>
-                <a:spcPts val="200"/>
-              </a:spcBef>
-            </a:pPr>
-            <a:r>
-              <a:rPr sz="1300">
-                <a:solidFill>
-                  <a:srgbClr val="666666"/>
-                </a:solidFill>
-                <a:latin typeface="Calibri"/>
-              </a:rPr>
-              <a:t>– ~3,900 edges recur in ≥8/10 bootstraps per unit (~7,600 at ≥7/10)</a:t>
+              <a:t>▸ Status: SC-Tiers 1–3 complete; Tier 4 (full pySCENIC, motif-pruned + bootstrap) complete for 4 headline cell types (see slide 17)</a:t>
             </a:r>
           </a:p>
         </p:txBody>
       </p:sp>
       <p:pic>
         <p:nvPicPr>
-          <p:cNvPr id="5" name="Picture 4" descr="sc_tier4_summary.png"/>
+          <p:cNvPr id="6" name="Picture 5" descr="v97ee8316_sc_synthesis.png"/>
           <p:cNvPicPr>
             <a:picLocks noChangeAspect="1"/>
           </p:cNvPicPr>
@@ -6285,8 +6320,8 @@
         </p:blipFill>
         <p:spPr>
           <a:xfrm>
-            <a:off x="7040880" y="1417320"/>
-            <a:ext cx="4846320" cy="1343497"/>
+            <a:off x="7635240" y="1554480"/>
+            <a:ext cx="4206240" cy="2085500"/>
           </a:xfrm>
           <a:prstGeom prst="rect">
             <a:avLst/>
@@ -6295,14 +6330,14 @@
       </p:pic>
       <p:sp>
         <p:nvSpPr>
-          <p:cNvPr id="6" name="TextBox 5"/>
+          <p:cNvPr id="7" name="TextBox 6"/>
           <p:cNvSpPr txBox="1"/>
           <p:nvPr/>
         </p:nvSpPr>
         <p:spPr>
           <a:xfrm>
-            <a:off x="7040880" y="4617720"/>
-            <a:ext cx="4846320" cy="365760"/>
+            <a:off x="7635240" y="4709160"/>
+            <a:ext cx="4206240" cy="365760"/>
           </a:xfrm>
           <a:prstGeom prst="rect">
             <a:avLst/>
@@ -6323,42 +6358,7 @@
                 </a:solidFill>
                 <a:latin typeface="Calibri"/>
               </a:rPr>
-              <a:t>Tier-4 conservation, master survival, and stability (4 cell types)</a:t>
-            </a:r>
-          </a:p>
-        </p:txBody>
-      </p:sp>
-      <p:sp>
-        <p:nvSpPr>
-          <p:cNvPr id="7" name="TextBox 6"/>
-          <p:cNvSpPr txBox="1"/>
-          <p:nvPr/>
-        </p:nvSpPr>
-        <p:spPr>
-          <a:xfrm>
-            <a:off x="11247120" y="6355080"/>
-            <a:ext cx="822960" cy="365760"/>
-          </a:xfrm>
-          <a:prstGeom prst="rect">
-            <a:avLst/>
-          </a:prstGeom>
-          <a:noFill/>
-        </p:spPr>
-        <p:txBody>
-          <a:bodyPr wrap="square">
-            <a:spAutoFit/>
-          </a:bodyPr>
-          <a:lstStyle/>
-          <a:p>
-            <a:pPr algn="r"/>
-            <a:r>
-              <a:rPr sz="1100" b="0">
-                <a:solidFill>
-                  <a:srgbClr val="666666"/>
-                </a:solidFill>
-                <a:latin typeface="Calibri"/>
-              </a:rPr>
-              <a:t>17 / 18</a:t>
+              <a:t>SC2.2: phylo-signal × preservation × cell-type regulon conservation</a:t>
             </a:r>
           </a:p>
         </p:txBody>

</xml_diff>